<commit_message>
W04 D1: the coverage matrix filled, the sources list locks each concept rule, the deck's minutes meet the envelope
The matrix maps the six subtopics to their chapters, slides, notebooks, items and
minutes, and each case chapter to the subtopics it applies; coverage_check passes.
The sources list adds the written reference behind each concept chapter's rule,
re-dates the public facts read again on 13 October 2026, lists the invented
examples and the rebuild's decisions. The generator's used_by strings and the
plants point at the new slides and notebook 12. On the deck, chapter 4 names the
lines that make a number computable, complaints are counted per 100 orders billed,
the Maxxsaver card quotes the letter's words, slide minutes now sum to 180 and 60,
and the close's six-topic strip became a table that fits.

Co-Authored-By: Claude Opus 5.5 <noreply@anthropic.com>
Claude-Session: https://claude.ai/code/session_01PKfnG4dDHtQtNuxCao8MwS
</commit_message>
<xml_diff>
--- a/content/W04/D1/slides/C2_W04_D01_half2_STUDENT.pptx
+++ b/content/W04/D1/slides/C2_W04_D01_half2_STUDENT.pptx
@@ -1372,7 +1372,7 @@
           <a:lstStyle/>
           <a:p>
             <a:r>
-              <a:t>LIVE, 2 minutes. Read the three cards in the roles' voices. The numbers on the cards come from the</a:t>
+              <a:t>LIVE, 2 minutes 30 seconds. Read the three cards in the roles' voices. The numbers on the cards come from the</a:t>
             </a:r>
           </a:p>
           <a:p>
@@ -1642,7 +1642,7 @@
           <a:lstStyle/>
           <a:p>
             <a:r>
-              <a:t>LIVE, 2 minutes. Groups compare their own saving with the range. A group that wrote "saves Rs 1.16</a:t>
+              <a:t>LIVE, 3 minutes: the comparison (2), then the scoring (1). Groups compare their own saving with the range. A group that wrote "saves Rs 1.16</a:t>
             </a:r>
           </a:p>
           <a:p>
@@ -1657,7 +1657,7 @@
           </a:p>
           <a:p>
             <a:r>
-              <a:t>the business is trying to do, and this one pays for trips. Then 1 minute of scoring.</a:t>
+              <a:t>the business is trying to do, and this one pays for trips. Then the scoring.</a:t>
             </a:r>
           </a:p>
           <a:p>
@@ -9994,7 +9994,7 @@
         <p:spPr>
           <a:xfrm>
             <a:off x="530352" y="1682496"/>
-            <a:ext cx="45720" cy="1889759"/>
+            <a:ext cx="45720" cy="1676400"/>
           </a:xfrm>
           <a:prstGeom prst="roundRect">
             <a:avLst>
@@ -10040,7 +10040,7 @@
         <p:spPr>
           <a:xfrm>
             <a:off x="786384" y="1682496"/>
-            <a:ext cx="4980279" cy="1889759"/>
+            <a:ext cx="4980279" cy="1676400"/>
           </a:xfrm>
           <a:prstGeom prst="rect">
             <a:avLst/>
@@ -10054,7 +10054,7 @@
           <a:lstStyle/>
           <a:p>
             <a:r>
-              <a:rPr sz="1600" b="0" i="1">
+              <a:rPr sz="1400" b="0" i="1">
                 <a:solidFill>
                   <a:srgbClr val="1A0F5C"/>
                 </a:solidFill>
@@ -10073,8 +10073,8 @@
         </p:nvSpPr>
         <p:spPr>
           <a:xfrm>
-            <a:off x="530352" y="3718560"/>
-            <a:ext cx="5291175" cy="1324864"/>
+            <a:off x="530352" y="3505200"/>
+            <a:ext cx="5291175" cy="944880"/>
           </a:xfrm>
           <a:prstGeom prst="rect">
             <a:avLst/>
@@ -10089,1299 +10089,379 @@
           <a:p>
             <a:pPr>
               <a:spcAft>
-                <a:spcPts val="800"/>
+                <a:spcPts val="700"/>
               </a:spcAft>
             </a:pPr>
             <a:r>
-              <a:rPr sz="1600" b="0" i="0">
+              <a:rPr sz="1400" b="0" i="0">
                 <a:solidFill>
                   <a:srgbClr val="1A1440"/>
                 </a:solidFill>
                 <a:latin typeface="Calibri"/>
               </a:rPr>
-              <a:t>The rule that follows from it: the Rs 300 floor stays only for driver-weeks that accept at least half their offers, an accepted trip later cancelled counting as declined.</a:t>
-            </a:r>
-          </a:p>
-        </p:txBody>
-      </p:sp>
-      <p:sp>
-        <p:nvSpPr>
-          <p:cNvPr id="12" name="Rectangle 11"/>
+              <a:t>The rule: the Rs 300 floor stays only for driver-weeks that accept at least half their offers, a cancelled trip counting as declined.</a:t>
+            </a:r>
+          </a:p>
+        </p:txBody>
+      </p:sp>
+      <p:graphicFrame>
+        <p:nvGraphicFramePr>
+          <p:cNvPr id="12" name="Table 11"/>
+          <p:cNvGraphicFramePr>
+            <a:graphicFrameLocks noGrp="1"/>
+          </p:cNvGraphicFramePr>
+          <p:nvPr/>
+        </p:nvGraphicFramePr>
+        <p:xfrm>
+          <a:off x="6370167" y="1682496"/>
+          <a:ext cx="5291175" cy="2554224"/>
+        </p:xfrm>
+        <a:graphic>
+          <a:graphicData uri="http://schemas.openxmlformats.org/drawingml/2006/table">
+            <a:tbl>
+              <a:tblPr firstRow="0" bandRow="0">
+                <a:tableStyleId>{2D5ABB26-0587-4C30-8999-92F81FD0307C}</a:tableStyleId>
+              </a:tblPr>
+              <a:tblGrid>
+                <a:gridCol w="2397009"/>
+                <a:gridCol w="2894166"/>
+              </a:tblGrid>
+              <a:tr h="335280">
+                <a:tc>
+                  <a:txBody>
+                    <a:bodyPr/>
+                    <a:lstStyle/>
+                    <a:p>
+                      <a:r>
+                        <a:rPr sz="1250" b="1" i="0">
+                          <a:solidFill>
+                            <a:srgbClr val="FFFFFF"/>
+                          </a:solidFill>
+                          <a:latin typeface="Calibri"/>
+                        </a:rPr>
+                        <a:t>Topic</a:t>
+                      </a:r>
+                    </a:p>
+                  </a:txBody>
+                  <a:tcPr marL="101600" marR="101600" marT="38100" marB="38100" anchor="ctr">
+                    <a:solidFill>
+                      <a:srgbClr val="1A0F5C"/>
+                    </a:solidFill>
+                  </a:tcPr>
+                </a:tc>
+                <a:tc>
+                  <a:txBody>
+                    <a:bodyPr/>
+                    <a:lstStyle/>
+                    <a:p>
+                      <a:r>
+                        <a:rPr sz="1250" b="1" i="0">
+                          <a:solidFill>
+                            <a:srgbClr val="FFFFFF"/>
+                          </a:solidFill>
+                          <a:latin typeface="Calibri"/>
+                        </a:rPr>
+                        <a:t>On Uber's scheme</a:t>
+                      </a:r>
+                    </a:p>
+                  </a:txBody>
+                  <a:tcPr marL="101600" marR="101600" marT="38100" marB="38100" anchor="ctr">
+                    <a:solidFill>
+                      <a:srgbClr val="1A0F5C"/>
+                    </a:solidFill>
+                  </a:tcPr>
+                </a:tc>
+              </a:tr>
+              <a:tr h="335280">
+                <a:tc>
+                  <a:txBody>
+                    <a:bodyPr/>
+                    <a:lstStyle/>
+                    <a:p>
+                      <a:r>
+                        <a:rPr sz="1200" b="0" i="0">
+                          <a:solidFill>
+                            <a:srgbClr val="1A1440"/>
+                          </a:solidFill>
+                          <a:latin typeface="Calibri"/>
+                        </a:rPr>
+                        <a:t>1. The proxy test</a:t>
+                      </a:r>
+                    </a:p>
+                  </a:txBody>
+                  <a:tcPr marL="101600" marR="101600" marT="38100" marB="38100" anchor="ctr">
+                    <a:solidFill>
+                      <a:srgbClr val="FFFFFF"/>
+                    </a:solidFill>
+                  </a:tcPr>
+                </a:tc>
+                <a:tc>
+                  <a:txBody>
+                    <a:bodyPr/>
+                    <a:lstStyle/>
+                    <a:p>
+                      <a:r>
+                        <a:rPr sz="1200" b="0" i="0">
+                          <a:solidFill>
+                            <a:srgbClr val="1A1440"/>
+                          </a:solidFill>
+                          <a:latin typeface="Calibri"/>
+                        </a:rPr>
+                        <a:t>Hours need no rider</a:t>
+                      </a:r>
+                    </a:p>
+                  </a:txBody>
+                  <a:tcPr marL="101600" marR="101600" marT="38100" marB="38100" anchor="ctr">
+                    <a:solidFill>
+                      <a:srgbClr val="FFFFFF"/>
+                    </a:solidFill>
+                  </a:tcPr>
+                </a:tc>
+              </a:tr>
+              <a:tr h="542544">
+                <a:tc>
+                  <a:txBody>
+                    <a:bodyPr/>
+                    <a:lstStyle/>
+                    <a:p>
+                      <a:r>
+                        <a:rPr sz="1200" b="0" i="0">
+                          <a:solidFill>
+                            <a:srgbClr val="1A1440"/>
+                          </a:solidFill>
+                          <a:latin typeface="Calibri"/>
+                        </a:rPr>
+                        <a:t>2. North star, guardrails</a:t>
+                      </a:r>
+                    </a:p>
+                  </a:txBody>
+                  <a:tcPr marL="101600" marR="101600" marT="38100" marB="38100" anchor="ctr">
+                    <a:solidFill>
+                      <a:srgbClr val="F4F2FA"/>
+                    </a:solidFill>
+                  </a:tcPr>
+                </a:tc>
+                <a:tc>
+                  <a:txBody>
+                    <a:bodyPr/>
+                    <a:lstStyle/>
+                    <a:p>
+                      <a:r>
+                        <a:rPr sz="1200" b="0" i="0">
+                          <a:solidFill>
+                            <a:srgbClr val="1A1440"/>
+                          </a:solidFill>
+                          <a:latin typeface="Calibri"/>
+                        </a:rPr>
+                        <a:t>Trips, with acceptance and the wait</a:t>
+                      </a:r>
+                    </a:p>
+                  </a:txBody>
+                  <a:tcPr marL="101600" marR="101600" marT="38100" marB="38100" anchor="ctr">
+                    <a:solidFill>
+                      <a:srgbClr val="F4F2FA"/>
+                    </a:solidFill>
+                  </a:tcPr>
+                </a:tc>
+              </a:tr>
+              <a:tr h="335280">
+                <a:tc>
+                  <a:txBody>
+                    <a:bodyPr/>
+                    <a:lstStyle/>
+                    <a:p>
+                      <a:r>
+                        <a:rPr sz="1200" b="0" i="0">
+                          <a:solidFill>
+                            <a:srgbClr val="1A1440"/>
+                          </a:solidFill>
+                          <a:latin typeface="Calibri"/>
+                        </a:rPr>
+                        <a:t>3. Leading, lagging</a:t>
+                      </a:r>
+                    </a:p>
+                  </a:txBody>
+                  <a:tcPr marL="101600" marR="101600" marT="38100" marB="38100" anchor="ctr">
+                    <a:solidFill>
+                      <a:srgbClr val="FFFFFF"/>
+                    </a:solidFill>
+                  </a:tcPr>
+                </a:tc>
+                <a:tc>
+                  <a:txBody>
+                    <a:bodyPr/>
+                    <a:lstStyle/>
+                    <a:p>
+                      <a:r>
+                        <a:rPr sz="1200" b="0" i="0">
+                          <a:solidFill>
+                            <a:srgbClr val="1A1440"/>
+                          </a:solidFill>
+                          <a:latin typeface="Calibri"/>
+                        </a:rPr>
+                        <a:t>Acceptance moved first</a:t>
+                      </a:r>
+                    </a:p>
+                  </a:txBody>
+                  <a:tcPr marL="101600" marR="101600" marT="38100" marB="38100" anchor="ctr">
+                    <a:solidFill>
+                      <a:srgbClr val="FFFFFF"/>
+                    </a:solidFill>
+                  </a:tcPr>
+                </a:tc>
+              </a:tr>
+              <a:tr h="335280">
+                <a:tc>
+                  <a:txBody>
+                    <a:bodyPr/>
+                    <a:lstStyle/>
+                    <a:p>
+                      <a:r>
+                        <a:rPr sz="1200" b="0" i="0">
+                          <a:solidFill>
+                            <a:srgbClr val="1A1440"/>
+                          </a:solidFill>
+                          <a:latin typeface="Calibri"/>
+                        </a:rPr>
+                        <a:t>4. The four lines</a:t>
+                      </a:r>
+                    </a:p>
+                  </a:txBody>
+                  <a:tcPr marL="101600" marR="101600" marT="38100" marB="38100" anchor="ctr">
+                    <a:solidFill>
+                      <a:srgbClr val="F4F2FA"/>
+                    </a:solidFill>
+                  </a:tcPr>
+                </a:tc>
+                <a:tc>
+                  <a:txBody>
+                    <a:bodyPr/>
+                    <a:lstStyle/>
+                    <a:p>
+                      <a:r>
+                        <a:rPr sz="1200" b="0" i="0">
+                          <a:solidFill>
+                            <a:srgbClr val="1A1440"/>
+                          </a:solidFill>
+                          <a:latin typeface="Calibri"/>
+                        </a:rPr>
+                        <a:t>All trips over all hours</a:t>
+                      </a:r>
+                    </a:p>
+                  </a:txBody>
+                  <a:tcPr marL="101600" marR="101600" marT="38100" marB="38100" anchor="ctr">
+                    <a:solidFill>
+                      <a:srgbClr val="F4F2FA"/>
+                    </a:solidFill>
+                  </a:tcPr>
+                </a:tc>
+              </a:tr>
+              <a:tr h="335280">
+                <a:tc>
+                  <a:txBody>
+                    <a:bodyPr/>
+                    <a:lstStyle/>
+                    <a:p>
+                      <a:r>
+                        <a:rPr sz="1200" b="0" i="0">
+                          <a:solidFill>
+                            <a:srgbClr val="1A1440"/>
+                          </a:solidFill>
+                          <a:latin typeface="Calibri"/>
+                        </a:rPr>
+                        <a:t>5. Gaming</a:t>
+                      </a:r>
+                    </a:p>
+                  </a:txBody>
+                  <a:tcPr marL="101600" marR="101600" marT="38100" marB="38100" anchor="ctr">
+                    <a:solidFill>
+                      <a:srgbClr val="FFFFFF"/>
+                    </a:solidFill>
+                  </a:tcPr>
+                </a:tc>
+                <a:tc>
+                  <a:txBody>
+                    <a:bodyPr/>
+                    <a:lstStyle/>
+                    <a:p>
+                      <a:r>
+                        <a:rPr sz="1200" b="0" i="0">
+                          <a:solidFill>
+                            <a:srgbClr val="1A1440"/>
+                          </a:solidFill>
+                          <a:latin typeface="Calibri"/>
+                        </a:rPr>
+                        <a:t>Pay for trips riders asked for</a:t>
+                      </a:r>
+                    </a:p>
+                  </a:txBody>
+                  <a:tcPr marL="101600" marR="101600" marT="38100" marB="38100" anchor="ctr">
+                    <a:solidFill>
+                      <a:srgbClr val="FFFFFF"/>
+                    </a:solidFill>
+                  </a:tcPr>
+                </a:tc>
+              </a:tr>
+              <a:tr h="335280">
+                <a:tc>
+                  <a:txBody>
+                    <a:bodyPr/>
+                    <a:lstStyle/>
+                    <a:p>
+                      <a:r>
+                        <a:rPr sz="1200" b="0" i="0">
+                          <a:solidFill>
+                            <a:srgbClr val="1A1440"/>
+                          </a:solidFill>
+                          <a:latin typeface="Calibri"/>
+                        </a:rPr>
+                        <a:t>6. The page</a:t>
+                      </a:r>
+                    </a:p>
+                  </a:txBody>
+                  <a:tcPr marL="101600" marR="101600" marT="38100" marB="38100" anchor="ctr">
+                    <a:solidFill>
+                      <a:srgbClr val="F4F2FA"/>
+                    </a:solidFill>
+                  </a:tcPr>
+                </a:tc>
+                <a:tc>
+                  <a:txBody>
+                    <a:bodyPr/>
+                    <a:lstStyle/>
+                    <a:p>
+                      <a:r>
+                        <a:rPr sz="1200" b="0" i="0">
+                          <a:solidFill>
+                            <a:srgbClr val="1A1440"/>
+                          </a:solidFill>
+                          <a:latin typeface="Calibri"/>
+                        </a:rPr>
+                        <a:t>Seven lines the city signs</a:t>
+                      </a:r>
+                    </a:p>
+                  </a:txBody>
+                  <a:tcPr marL="101600" marR="101600" marT="38100" marB="38100" anchor="ctr">
+                    <a:solidFill>
+                      <a:srgbClr val="F4F2FA"/>
+                    </a:solidFill>
+                  </a:tcPr>
+                </a:tc>
+              </a:tr>
+            </a:tbl>
+          </a:graphicData>
+        </a:graphic>
+      </p:graphicFrame>
+      <p:sp>
+        <p:nvSpPr>
+          <p:cNvPr id="13" name="Rounded Rectangle 12"/>
           <p:cNvSpPr/>
           <p:nvPr/>
         </p:nvSpPr>
         <p:spPr>
           <a:xfrm>
-            <a:off x="6734898" y="2249424"/>
-            <a:ext cx="4561713" cy="18288"/>
-          </a:xfrm>
-          <a:prstGeom prst="rect">
-            <a:avLst/>
-          </a:prstGeom>
-          <a:solidFill>
-            <a:srgbClr val="CFC9EE"/>
-          </a:solidFill>
-          <a:ln>
-            <a:noFill/>
-          </a:ln>
-          <a:effectLst/>
-        </p:spPr>
-        <p:style>
-          <a:lnRef idx="1">
-            <a:schemeClr val="accent1"/>
-          </a:lnRef>
-          <a:fillRef idx="3">
-            <a:schemeClr val="accent1"/>
-          </a:fillRef>
-          <a:effectRef idx="2">
-            <a:schemeClr val="accent1"/>
-          </a:effectRef>
-          <a:fontRef idx="minor">
-            <a:schemeClr val="lt1"/>
-          </a:fontRef>
-        </p:style>
-        <p:txBody>
-          <a:bodyPr rtlCol="0" anchor="ctr" wrap="square"/>
-          <a:lstStyle/>
-          <a:p>
-            <a:pPr algn="ctr"/>
-          </a:p>
-        </p:txBody>
-      </p:sp>
-      <p:sp>
-        <p:nvSpPr>
-          <p:cNvPr id="13" name="TextBox 12"/>
-          <p:cNvSpPr txBox="1"/>
-          <p:nvPr/>
-        </p:nvSpPr>
-        <p:spPr>
-          <a:xfrm>
-            <a:off x="6370167" y="1682496"/>
-            <a:ext cx="729462" cy="168656"/>
-          </a:xfrm>
-          <a:prstGeom prst="rect">
-            <a:avLst/>
-          </a:prstGeom>
-          <a:noFill/>
-        </p:spPr>
-        <p:txBody>
-          <a:bodyPr wrap="square" anchor="t" lIns="0" rIns="0" tIns="0" bIns="0">
-            <a:spAutoFit/>
-          </a:bodyPr>
-          <a:lstStyle/>
-          <a:p>
-            <a:pPr algn="ctr"/>
-            <a:r>
-              <a:rPr sz="800" b="1" i="0" spc="250">
-                <a:solidFill>
-                  <a:srgbClr val="5B3FD6"/>
-                </a:solidFill>
-                <a:latin typeface="Calibri"/>
-              </a:rPr>
-              <a:t>1</a:t>
-            </a:r>
-          </a:p>
-        </p:txBody>
-      </p:sp>
-      <p:sp>
-        <p:nvSpPr>
-          <p:cNvPr id="14" name="Oval 13"/>
-          <p:cNvSpPr/>
-          <p:nvPr/>
-        </p:nvSpPr>
-        <p:spPr>
-          <a:xfrm>
-            <a:off x="6634314" y="2157984"/>
-            <a:ext cx="201168" cy="201168"/>
-          </a:xfrm>
-          <a:prstGeom prst="ellipse">
-            <a:avLst/>
-          </a:prstGeom>
-          <a:solidFill>
-            <a:srgbClr val="5B3FD6"/>
-          </a:solidFill>
-          <a:ln>
-            <a:noFill/>
-          </a:ln>
-          <a:effectLst/>
-        </p:spPr>
-        <p:style>
-          <a:lnRef idx="1">
-            <a:schemeClr val="accent1"/>
-          </a:lnRef>
-          <a:fillRef idx="3">
-            <a:schemeClr val="accent1"/>
-          </a:fillRef>
-          <a:effectRef idx="2">
-            <a:schemeClr val="accent1"/>
-          </a:effectRef>
-          <a:fontRef idx="minor">
-            <a:schemeClr val="lt1"/>
-          </a:fontRef>
-        </p:style>
-        <p:txBody>
-          <a:bodyPr rtlCol="0" anchor="ctr" wrap="square"/>
-          <a:lstStyle/>
-          <a:p>
-            <a:pPr algn="ctr"/>
-          </a:p>
-        </p:txBody>
-      </p:sp>
-      <p:sp>
-        <p:nvSpPr>
-          <p:cNvPr id="15" name="Rounded Rectangle 14"/>
-          <p:cNvSpPr/>
-          <p:nvPr/>
-        </p:nvSpPr>
-        <p:spPr>
-          <a:xfrm>
-            <a:off x="6370167" y="2569464"/>
-            <a:ext cx="729462" cy="1940560"/>
-          </a:xfrm>
-          <a:prstGeom prst="roundRect">
-            <a:avLst>
-              <a:gd name="adj" fmla="val 5000"/>
-            </a:avLst>
-          </a:prstGeom>
-          <a:solidFill>
-            <a:srgbClr val="FFFFFF"/>
-          </a:solidFill>
-          <a:ln w="9525">
-            <a:solidFill>
-              <a:srgbClr val="E4E1F1"/>
-            </a:solidFill>
-          </a:ln>
-          <a:effectLst>
-            <a:outerShdw blurRad="76200" dist="19050" dir="5400000" algn="bl" rotWithShape="0">
-              <a:srgbClr val="1A0F5C">
-                <a:alpha val="12000"/>
-              </a:srgbClr>
-            </a:outerShdw>
-          </a:effectLst>
-        </p:spPr>
-        <p:style>
-          <a:lnRef idx="1">
-            <a:schemeClr val="accent1"/>
-          </a:lnRef>
-          <a:fillRef idx="3">
-            <a:schemeClr val="accent1"/>
-          </a:fillRef>
-          <a:effectRef idx="2">
-            <a:schemeClr val="accent1"/>
-          </a:effectRef>
-          <a:fontRef idx="minor">
-            <a:schemeClr val="lt1"/>
-          </a:fontRef>
-        </p:style>
-        <p:txBody>
-          <a:bodyPr rtlCol="0" anchor="ctr" wrap="square"/>
-          <a:lstStyle/>
-          <a:p>
-            <a:pPr algn="ctr"/>
-          </a:p>
-        </p:txBody>
-      </p:sp>
-      <p:sp>
-        <p:nvSpPr>
-          <p:cNvPr id="16" name="TextBox 15"/>
-          <p:cNvSpPr txBox="1"/>
-          <p:nvPr/>
-        </p:nvSpPr>
-        <p:spPr>
-          <a:xfrm>
-            <a:off x="6534759" y="2715768"/>
-            <a:ext cx="400278" cy="465836"/>
-          </a:xfrm>
-          <a:prstGeom prst="rect">
-            <a:avLst/>
-          </a:prstGeom>
-          <a:noFill/>
-        </p:spPr>
-        <p:txBody>
-          <a:bodyPr wrap="square" anchor="t" lIns="0" rIns="0" tIns="0" bIns="0">
-            <a:spAutoFit/>
-          </a:bodyPr>
-          <a:lstStyle/>
-          <a:p>
-            <a:pPr algn="l"/>
-            <a:r>
-              <a:rPr sz="1300" b="1" i="0">
-                <a:solidFill>
-                  <a:srgbClr val="1A0F5C"/>
-                </a:solidFill>
-                <a:latin typeface="Calibri"/>
-              </a:rPr>
-              <a:t>The proxy test</a:t>
-            </a:r>
-          </a:p>
-        </p:txBody>
-      </p:sp>
-      <p:sp>
-        <p:nvSpPr>
-          <p:cNvPr id="17" name="TextBox 16"/>
-          <p:cNvSpPr txBox="1"/>
-          <p:nvPr/>
-        </p:nvSpPr>
-        <p:spPr>
-          <a:xfrm>
-            <a:off x="6534759" y="3218180"/>
-            <a:ext cx="400278" cy="696976"/>
-          </a:xfrm>
-          <a:prstGeom prst="rect">
-            <a:avLst/>
-          </a:prstGeom>
-          <a:noFill/>
-        </p:spPr>
-        <p:txBody>
-          <a:bodyPr wrap="square" anchor="t" lIns="0" rIns="0" tIns="0" bIns="0">
-            <a:spAutoFit/>
-          </a:bodyPr>
-          <a:lstStyle/>
-          <a:p>
-            <a:pPr algn="l"/>
-            <a:r>
-              <a:rPr sz="1000" b="0" i="0">
-                <a:solidFill>
-                  <a:srgbClr val="6B6690"/>
-                </a:solidFill>
-                <a:latin typeface="Calibri"/>
-              </a:rPr>
-              <a:t>Hours need no rider; trips do.</a:t>
-            </a:r>
-          </a:p>
-        </p:txBody>
-      </p:sp>
-      <p:sp>
-        <p:nvSpPr>
-          <p:cNvPr id="18" name="TextBox 17"/>
-          <p:cNvSpPr txBox="1"/>
-          <p:nvPr/>
-        </p:nvSpPr>
-        <p:spPr>
-          <a:xfrm>
-            <a:off x="7282510" y="1682496"/>
-            <a:ext cx="729462" cy="168656"/>
-          </a:xfrm>
-          <a:prstGeom prst="rect">
-            <a:avLst/>
-          </a:prstGeom>
-          <a:noFill/>
-        </p:spPr>
-        <p:txBody>
-          <a:bodyPr wrap="square" anchor="t" lIns="0" rIns="0" tIns="0" bIns="0">
-            <a:spAutoFit/>
-          </a:bodyPr>
-          <a:lstStyle/>
-          <a:p>
-            <a:pPr algn="ctr"/>
-            <a:r>
-              <a:rPr sz="800" b="1" i="0" spc="250">
-                <a:solidFill>
-                  <a:srgbClr val="5B3FD6"/>
-                </a:solidFill>
-                <a:latin typeface="Calibri"/>
-              </a:rPr>
-              <a:t>2</a:t>
-            </a:r>
-          </a:p>
-        </p:txBody>
-      </p:sp>
-      <p:sp>
-        <p:nvSpPr>
-          <p:cNvPr id="19" name="Oval 18"/>
-          <p:cNvSpPr/>
-          <p:nvPr/>
-        </p:nvSpPr>
-        <p:spPr>
-          <a:xfrm>
-            <a:off x="7546657" y="2157984"/>
-            <a:ext cx="201168" cy="201168"/>
-          </a:xfrm>
-          <a:prstGeom prst="ellipse">
-            <a:avLst/>
-          </a:prstGeom>
-          <a:solidFill>
-            <a:srgbClr val="5B3FD6"/>
-          </a:solidFill>
-          <a:ln>
-            <a:noFill/>
-          </a:ln>
-          <a:effectLst/>
-        </p:spPr>
-        <p:style>
-          <a:lnRef idx="1">
-            <a:schemeClr val="accent1"/>
-          </a:lnRef>
-          <a:fillRef idx="3">
-            <a:schemeClr val="accent1"/>
-          </a:fillRef>
-          <a:effectRef idx="2">
-            <a:schemeClr val="accent1"/>
-          </a:effectRef>
-          <a:fontRef idx="minor">
-            <a:schemeClr val="lt1"/>
-          </a:fontRef>
-        </p:style>
-        <p:txBody>
-          <a:bodyPr rtlCol="0" anchor="ctr" wrap="square"/>
-          <a:lstStyle/>
-          <a:p>
-            <a:pPr algn="ctr"/>
-          </a:p>
-        </p:txBody>
-      </p:sp>
-      <p:sp>
-        <p:nvSpPr>
-          <p:cNvPr id="20" name="Rounded Rectangle 19"/>
-          <p:cNvSpPr/>
-          <p:nvPr/>
-        </p:nvSpPr>
-        <p:spPr>
-          <a:xfrm>
-            <a:off x="7282510" y="2569464"/>
-            <a:ext cx="729462" cy="1940560"/>
-          </a:xfrm>
-          <a:prstGeom prst="roundRect">
-            <a:avLst>
-              <a:gd name="adj" fmla="val 5000"/>
-            </a:avLst>
-          </a:prstGeom>
-          <a:solidFill>
-            <a:srgbClr val="FFFFFF"/>
-          </a:solidFill>
-          <a:ln w="9525">
-            <a:solidFill>
-              <a:srgbClr val="E4E1F1"/>
-            </a:solidFill>
-          </a:ln>
-          <a:effectLst>
-            <a:outerShdw blurRad="76200" dist="19050" dir="5400000" algn="bl" rotWithShape="0">
-              <a:srgbClr val="1A0F5C">
-                <a:alpha val="12000"/>
-              </a:srgbClr>
-            </a:outerShdw>
-          </a:effectLst>
-        </p:spPr>
-        <p:style>
-          <a:lnRef idx="1">
-            <a:schemeClr val="accent1"/>
-          </a:lnRef>
-          <a:fillRef idx="3">
-            <a:schemeClr val="accent1"/>
-          </a:fillRef>
-          <a:effectRef idx="2">
-            <a:schemeClr val="accent1"/>
-          </a:effectRef>
-          <a:fontRef idx="minor">
-            <a:schemeClr val="lt1"/>
-          </a:fontRef>
-        </p:style>
-        <p:txBody>
-          <a:bodyPr rtlCol="0" anchor="ctr" wrap="square"/>
-          <a:lstStyle/>
-          <a:p>
-            <a:pPr algn="ctr"/>
-          </a:p>
-        </p:txBody>
-      </p:sp>
-      <p:sp>
-        <p:nvSpPr>
-          <p:cNvPr id="21" name="TextBox 20"/>
-          <p:cNvSpPr txBox="1"/>
-          <p:nvPr/>
-        </p:nvSpPr>
-        <p:spPr>
-          <a:xfrm>
-            <a:off x="7447102" y="2715768"/>
-            <a:ext cx="400278" cy="895096"/>
-          </a:xfrm>
-          <a:prstGeom prst="rect">
-            <a:avLst/>
-          </a:prstGeom>
-          <a:noFill/>
-        </p:spPr>
-        <p:txBody>
-          <a:bodyPr wrap="square" anchor="t" lIns="0" rIns="0" tIns="0" bIns="0">
-            <a:spAutoFit/>
-          </a:bodyPr>
-          <a:lstStyle/>
-          <a:p>
-            <a:pPr algn="l"/>
-            <a:r>
-              <a:rPr sz="1300" b="1" i="0">
-                <a:solidFill>
-                  <a:srgbClr val="1A0F5C"/>
-                </a:solidFill>
-                <a:latin typeface="Calibri"/>
-              </a:rPr>
-              <a:t>North star and guardrails</a:t>
-            </a:r>
-          </a:p>
-        </p:txBody>
-      </p:sp>
-      <p:sp>
-        <p:nvSpPr>
-          <p:cNvPr id="22" name="TextBox 21"/>
-          <p:cNvSpPr txBox="1"/>
-          <p:nvPr/>
-        </p:nvSpPr>
-        <p:spPr>
-          <a:xfrm>
-            <a:off x="7447102" y="3647440"/>
-            <a:ext cx="400278" cy="1192276"/>
-          </a:xfrm>
-          <a:prstGeom prst="rect">
-            <a:avLst/>
-          </a:prstGeom>
-          <a:noFill/>
-        </p:spPr>
-        <p:txBody>
-          <a:bodyPr wrap="square" anchor="t" lIns="0" rIns="0" tIns="0" bIns="0">
-            <a:spAutoFit/>
-          </a:bodyPr>
-          <a:lstStyle/>
-          <a:p>
-            <a:pPr algn="l"/>
-            <a:r>
-              <a:rPr sz="1000" b="0" i="0">
-                <a:solidFill>
-                  <a:srgbClr val="6B6690"/>
-                </a:solidFill>
-                <a:latin typeface="Calibri"/>
-              </a:rPr>
-              <a:t>Trips per enrolled driver, with acceptance and the wait.</a:t>
-            </a:r>
-          </a:p>
-        </p:txBody>
-      </p:sp>
-      <p:sp>
-        <p:nvSpPr>
-          <p:cNvPr id="23" name="TextBox 22"/>
-          <p:cNvSpPr txBox="1"/>
-          <p:nvPr/>
-        </p:nvSpPr>
-        <p:spPr>
-          <a:xfrm>
-            <a:off x="8194852" y="1682496"/>
-            <a:ext cx="729462" cy="168656"/>
-          </a:xfrm>
-          <a:prstGeom prst="rect">
-            <a:avLst/>
-          </a:prstGeom>
-          <a:noFill/>
-        </p:spPr>
-        <p:txBody>
-          <a:bodyPr wrap="square" anchor="t" lIns="0" rIns="0" tIns="0" bIns="0">
-            <a:spAutoFit/>
-          </a:bodyPr>
-          <a:lstStyle/>
-          <a:p>
-            <a:pPr algn="ctr"/>
-            <a:r>
-              <a:rPr sz="800" b="1" i="0" spc="250">
-                <a:solidFill>
-                  <a:srgbClr val="5B3FD6"/>
-                </a:solidFill>
-                <a:latin typeface="Calibri"/>
-              </a:rPr>
-              <a:t>3</a:t>
-            </a:r>
-          </a:p>
-        </p:txBody>
-      </p:sp>
-      <p:sp>
-        <p:nvSpPr>
-          <p:cNvPr id="24" name="Oval 23"/>
-          <p:cNvSpPr/>
-          <p:nvPr/>
-        </p:nvSpPr>
-        <p:spPr>
-          <a:xfrm>
-            <a:off x="8459000" y="2157984"/>
-            <a:ext cx="201168" cy="201168"/>
-          </a:xfrm>
-          <a:prstGeom prst="ellipse">
-            <a:avLst/>
-          </a:prstGeom>
-          <a:solidFill>
-            <a:srgbClr val="5B3FD6"/>
-          </a:solidFill>
-          <a:ln>
-            <a:noFill/>
-          </a:ln>
-          <a:effectLst/>
-        </p:spPr>
-        <p:style>
-          <a:lnRef idx="1">
-            <a:schemeClr val="accent1"/>
-          </a:lnRef>
-          <a:fillRef idx="3">
-            <a:schemeClr val="accent1"/>
-          </a:fillRef>
-          <a:effectRef idx="2">
-            <a:schemeClr val="accent1"/>
-          </a:effectRef>
-          <a:fontRef idx="minor">
-            <a:schemeClr val="lt1"/>
-          </a:fontRef>
-        </p:style>
-        <p:txBody>
-          <a:bodyPr rtlCol="0" anchor="ctr" wrap="square"/>
-          <a:lstStyle/>
-          <a:p>
-            <a:pPr algn="ctr"/>
-          </a:p>
-        </p:txBody>
-      </p:sp>
-      <p:sp>
-        <p:nvSpPr>
-          <p:cNvPr id="25" name="Rounded Rectangle 24"/>
-          <p:cNvSpPr/>
-          <p:nvPr/>
-        </p:nvSpPr>
-        <p:spPr>
-          <a:xfrm>
-            <a:off x="8194852" y="2569464"/>
-            <a:ext cx="729462" cy="1940560"/>
-          </a:xfrm>
-          <a:prstGeom prst="roundRect">
-            <a:avLst>
-              <a:gd name="adj" fmla="val 5000"/>
-            </a:avLst>
-          </a:prstGeom>
-          <a:solidFill>
-            <a:srgbClr val="FFFFFF"/>
-          </a:solidFill>
-          <a:ln w="9525">
-            <a:solidFill>
-              <a:srgbClr val="E4E1F1"/>
-            </a:solidFill>
-          </a:ln>
-          <a:effectLst>
-            <a:outerShdw blurRad="76200" dist="19050" dir="5400000" algn="bl" rotWithShape="0">
-              <a:srgbClr val="1A0F5C">
-                <a:alpha val="12000"/>
-              </a:srgbClr>
-            </a:outerShdw>
-          </a:effectLst>
-        </p:spPr>
-        <p:style>
-          <a:lnRef idx="1">
-            <a:schemeClr val="accent1"/>
-          </a:lnRef>
-          <a:fillRef idx="3">
-            <a:schemeClr val="accent1"/>
-          </a:fillRef>
-          <a:effectRef idx="2">
-            <a:schemeClr val="accent1"/>
-          </a:effectRef>
-          <a:fontRef idx="minor">
-            <a:schemeClr val="lt1"/>
-          </a:fontRef>
-        </p:style>
-        <p:txBody>
-          <a:bodyPr rtlCol="0" anchor="ctr" wrap="square"/>
-          <a:lstStyle/>
-          <a:p>
-            <a:pPr algn="ctr"/>
-          </a:p>
-        </p:txBody>
-      </p:sp>
-      <p:sp>
-        <p:nvSpPr>
-          <p:cNvPr id="26" name="TextBox 25"/>
-          <p:cNvSpPr txBox="1"/>
-          <p:nvPr/>
-        </p:nvSpPr>
-        <p:spPr>
-          <a:xfrm>
-            <a:off x="8359444" y="2715768"/>
-            <a:ext cx="400278" cy="680466"/>
-          </a:xfrm>
-          <a:prstGeom prst="rect">
-            <a:avLst/>
-          </a:prstGeom>
-          <a:noFill/>
-        </p:spPr>
-        <p:txBody>
-          <a:bodyPr wrap="square" anchor="t" lIns="0" rIns="0" tIns="0" bIns="0">
-            <a:spAutoFit/>
-          </a:bodyPr>
-          <a:lstStyle/>
-          <a:p>
-            <a:pPr algn="l"/>
-            <a:r>
-              <a:rPr sz="1300" b="1" i="0">
-                <a:solidFill>
-                  <a:srgbClr val="1A0F5C"/>
-                </a:solidFill>
-                <a:latin typeface="Calibri"/>
-              </a:rPr>
-              <a:t>Leading and lagging</a:t>
-            </a:r>
-          </a:p>
-        </p:txBody>
-      </p:sp>
-      <p:sp>
-        <p:nvSpPr>
-          <p:cNvPr id="27" name="TextBox 26"/>
-          <p:cNvSpPr txBox="1"/>
-          <p:nvPr/>
-        </p:nvSpPr>
-        <p:spPr>
-          <a:xfrm>
-            <a:off x="8359444" y="3432810"/>
-            <a:ext cx="400278" cy="862076"/>
-          </a:xfrm>
-          <a:prstGeom prst="rect">
-            <a:avLst/>
-          </a:prstGeom>
-          <a:noFill/>
-        </p:spPr>
-        <p:txBody>
-          <a:bodyPr wrap="square" anchor="t" lIns="0" rIns="0" tIns="0" bIns="0">
-            <a:spAutoFit/>
-          </a:bodyPr>
-          <a:lstStyle/>
-          <a:p>
-            <a:pPr algn="l"/>
-            <a:r>
-              <a:rPr sz="1000" b="0" i="0">
-                <a:solidFill>
-                  <a:srgbClr val="6B6690"/>
-                </a:solidFill>
-                <a:latin typeface="Calibri"/>
-              </a:rPr>
-              <a:t>Acceptance moved in the launch week.</a:t>
-            </a:r>
-          </a:p>
-        </p:txBody>
-      </p:sp>
-      <p:sp>
-        <p:nvSpPr>
-          <p:cNvPr id="28" name="TextBox 27"/>
-          <p:cNvSpPr txBox="1"/>
-          <p:nvPr/>
-        </p:nvSpPr>
-        <p:spPr>
-          <a:xfrm>
-            <a:off x="9107195" y="1682496"/>
-            <a:ext cx="729462" cy="168656"/>
-          </a:xfrm>
-          <a:prstGeom prst="rect">
-            <a:avLst/>
-          </a:prstGeom>
-          <a:noFill/>
-        </p:spPr>
-        <p:txBody>
-          <a:bodyPr wrap="square" anchor="t" lIns="0" rIns="0" tIns="0" bIns="0">
-            <a:spAutoFit/>
-          </a:bodyPr>
-          <a:lstStyle/>
-          <a:p>
-            <a:pPr algn="ctr"/>
-            <a:r>
-              <a:rPr sz="800" b="1" i="0" spc="250">
-                <a:solidFill>
-                  <a:srgbClr val="5B3FD6"/>
-                </a:solidFill>
-                <a:latin typeface="Calibri"/>
-              </a:rPr>
-              <a:t>4</a:t>
-            </a:r>
-          </a:p>
-        </p:txBody>
-      </p:sp>
-      <p:sp>
-        <p:nvSpPr>
-          <p:cNvPr id="29" name="Oval 28"/>
-          <p:cNvSpPr/>
-          <p:nvPr/>
-        </p:nvSpPr>
-        <p:spPr>
-          <a:xfrm>
-            <a:off x="9371342" y="2157984"/>
-            <a:ext cx="201168" cy="201168"/>
-          </a:xfrm>
-          <a:prstGeom prst="ellipse">
-            <a:avLst/>
-          </a:prstGeom>
-          <a:solidFill>
-            <a:srgbClr val="5B3FD6"/>
-          </a:solidFill>
-          <a:ln>
-            <a:noFill/>
-          </a:ln>
-          <a:effectLst/>
-        </p:spPr>
-        <p:style>
-          <a:lnRef idx="1">
-            <a:schemeClr val="accent1"/>
-          </a:lnRef>
-          <a:fillRef idx="3">
-            <a:schemeClr val="accent1"/>
-          </a:fillRef>
-          <a:effectRef idx="2">
-            <a:schemeClr val="accent1"/>
-          </a:effectRef>
-          <a:fontRef idx="minor">
-            <a:schemeClr val="lt1"/>
-          </a:fontRef>
-        </p:style>
-        <p:txBody>
-          <a:bodyPr rtlCol="0" anchor="ctr" wrap="square"/>
-          <a:lstStyle/>
-          <a:p>
-            <a:pPr algn="ctr"/>
-          </a:p>
-        </p:txBody>
-      </p:sp>
-      <p:sp>
-        <p:nvSpPr>
-          <p:cNvPr id="30" name="Rounded Rectangle 29"/>
-          <p:cNvSpPr/>
-          <p:nvPr/>
-        </p:nvSpPr>
-        <p:spPr>
-          <a:xfrm>
-            <a:off x="9107195" y="2569464"/>
-            <a:ext cx="729462" cy="1940560"/>
-          </a:xfrm>
-          <a:prstGeom prst="roundRect">
-            <a:avLst>
-              <a:gd name="adj" fmla="val 5000"/>
-            </a:avLst>
-          </a:prstGeom>
-          <a:solidFill>
-            <a:srgbClr val="FFFFFF"/>
-          </a:solidFill>
-          <a:ln w="9525">
-            <a:solidFill>
-              <a:srgbClr val="E4E1F1"/>
-            </a:solidFill>
-          </a:ln>
-          <a:effectLst>
-            <a:outerShdw blurRad="76200" dist="19050" dir="5400000" algn="bl" rotWithShape="0">
-              <a:srgbClr val="1A0F5C">
-                <a:alpha val="12000"/>
-              </a:srgbClr>
-            </a:outerShdw>
-          </a:effectLst>
-        </p:spPr>
-        <p:style>
-          <a:lnRef idx="1">
-            <a:schemeClr val="accent1"/>
-          </a:lnRef>
-          <a:fillRef idx="3">
-            <a:schemeClr val="accent1"/>
-          </a:fillRef>
-          <a:effectRef idx="2">
-            <a:schemeClr val="accent1"/>
-          </a:effectRef>
-          <a:fontRef idx="minor">
-            <a:schemeClr val="lt1"/>
-          </a:fontRef>
-        </p:style>
-        <p:txBody>
-          <a:bodyPr rtlCol="0" anchor="ctr" wrap="square"/>
-          <a:lstStyle/>
-          <a:p>
-            <a:pPr algn="ctr"/>
-          </a:p>
-        </p:txBody>
-      </p:sp>
-      <p:sp>
-        <p:nvSpPr>
-          <p:cNvPr id="31" name="TextBox 30"/>
-          <p:cNvSpPr txBox="1"/>
-          <p:nvPr/>
-        </p:nvSpPr>
-        <p:spPr>
-          <a:xfrm>
-            <a:off x="9271787" y="2715768"/>
-            <a:ext cx="400278" cy="465836"/>
-          </a:xfrm>
-          <a:prstGeom prst="rect">
-            <a:avLst/>
-          </a:prstGeom>
-          <a:noFill/>
-        </p:spPr>
-        <p:txBody>
-          <a:bodyPr wrap="square" anchor="t" lIns="0" rIns="0" tIns="0" bIns="0">
-            <a:spAutoFit/>
-          </a:bodyPr>
-          <a:lstStyle/>
-          <a:p>
-            <a:pPr algn="l"/>
-            <a:r>
-              <a:rPr sz="1300" b="1" i="0">
-                <a:solidFill>
-                  <a:srgbClr val="1A0F5C"/>
-                </a:solidFill>
-                <a:latin typeface="Calibri"/>
-              </a:rPr>
-              <a:t>The four lines</a:t>
-            </a:r>
-          </a:p>
-        </p:txBody>
-      </p:sp>
-      <p:sp>
-        <p:nvSpPr>
-          <p:cNvPr id="32" name="TextBox 31"/>
-          <p:cNvSpPr txBox="1"/>
-          <p:nvPr/>
-        </p:nvSpPr>
-        <p:spPr>
-          <a:xfrm>
-            <a:off x="9271787" y="3218180"/>
-            <a:ext cx="400278" cy="862076"/>
-          </a:xfrm>
-          <a:prstGeom prst="rect">
-            <a:avLst/>
-          </a:prstGeom>
-          <a:noFill/>
-        </p:spPr>
-        <p:txBody>
-          <a:bodyPr wrap="square" anchor="t" lIns="0" rIns="0" tIns="0" bIns="0">
-            <a:spAutoFit/>
-          </a:bodyPr>
-          <a:lstStyle/>
-          <a:p>
-            <a:pPr algn="l"/>
-            <a:r>
-              <a:rPr sz="1000" b="0" i="0">
-                <a:solidFill>
-                  <a:srgbClr val="6B6690"/>
-                </a:solidFill>
-                <a:latin typeface="Calibri"/>
-              </a:rPr>
-              <a:t>A ratio of sums, its denominator named.</a:t>
-            </a:r>
-          </a:p>
-        </p:txBody>
-      </p:sp>
-      <p:sp>
-        <p:nvSpPr>
-          <p:cNvPr id="33" name="TextBox 32"/>
-          <p:cNvSpPr txBox="1"/>
-          <p:nvPr/>
-        </p:nvSpPr>
-        <p:spPr>
-          <a:xfrm>
-            <a:off x="10019538" y="1682496"/>
-            <a:ext cx="729462" cy="168656"/>
-          </a:xfrm>
-          <a:prstGeom prst="rect">
-            <a:avLst/>
-          </a:prstGeom>
-          <a:noFill/>
-        </p:spPr>
-        <p:txBody>
-          <a:bodyPr wrap="square" anchor="t" lIns="0" rIns="0" tIns="0" bIns="0">
-            <a:spAutoFit/>
-          </a:bodyPr>
-          <a:lstStyle/>
-          <a:p>
-            <a:pPr algn="ctr"/>
-            <a:r>
-              <a:rPr sz="800" b="1" i="0" spc="250">
-                <a:solidFill>
-                  <a:srgbClr val="5B3FD6"/>
-                </a:solidFill>
-                <a:latin typeface="Calibri"/>
-              </a:rPr>
-              <a:t>5</a:t>
-            </a:r>
-          </a:p>
-        </p:txBody>
-      </p:sp>
-      <p:sp>
-        <p:nvSpPr>
-          <p:cNvPr id="34" name="Oval 33"/>
-          <p:cNvSpPr/>
-          <p:nvPr/>
-        </p:nvSpPr>
-        <p:spPr>
-          <a:xfrm>
-            <a:off x="10283685" y="2157984"/>
-            <a:ext cx="201168" cy="201168"/>
-          </a:xfrm>
-          <a:prstGeom prst="ellipse">
-            <a:avLst/>
-          </a:prstGeom>
-          <a:solidFill>
-            <a:srgbClr val="5B3FD6"/>
-          </a:solidFill>
-          <a:ln>
-            <a:noFill/>
-          </a:ln>
-          <a:effectLst/>
-        </p:spPr>
-        <p:style>
-          <a:lnRef idx="1">
-            <a:schemeClr val="accent1"/>
-          </a:lnRef>
-          <a:fillRef idx="3">
-            <a:schemeClr val="accent1"/>
-          </a:fillRef>
-          <a:effectRef idx="2">
-            <a:schemeClr val="accent1"/>
-          </a:effectRef>
-          <a:fontRef idx="minor">
-            <a:schemeClr val="lt1"/>
-          </a:fontRef>
-        </p:style>
-        <p:txBody>
-          <a:bodyPr rtlCol="0" anchor="ctr" wrap="square"/>
-          <a:lstStyle/>
-          <a:p>
-            <a:pPr algn="ctr"/>
-          </a:p>
-        </p:txBody>
-      </p:sp>
-      <p:sp>
-        <p:nvSpPr>
-          <p:cNvPr id="35" name="Rounded Rectangle 34"/>
-          <p:cNvSpPr/>
-          <p:nvPr/>
-        </p:nvSpPr>
-        <p:spPr>
-          <a:xfrm>
-            <a:off x="10019538" y="2569464"/>
-            <a:ext cx="729462" cy="1940560"/>
-          </a:xfrm>
-          <a:prstGeom prst="roundRect">
-            <a:avLst>
-              <a:gd name="adj" fmla="val 5000"/>
-            </a:avLst>
-          </a:prstGeom>
-          <a:solidFill>
-            <a:srgbClr val="FFFFFF"/>
-          </a:solidFill>
-          <a:ln w="9525">
-            <a:solidFill>
-              <a:srgbClr val="E4E1F1"/>
-            </a:solidFill>
-          </a:ln>
-          <a:effectLst>
-            <a:outerShdw blurRad="76200" dist="19050" dir="5400000" algn="bl" rotWithShape="0">
-              <a:srgbClr val="1A0F5C">
-                <a:alpha val="12000"/>
-              </a:srgbClr>
-            </a:outerShdw>
-          </a:effectLst>
-        </p:spPr>
-        <p:style>
-          <a:lnRef idx="1">
-            <a:schemeClr val="accent1"/>
-          </a:lnRef>
-          <a:fillRef idx="3">
-            <a:schemeClr val="accent1"/>
-          </a:fillRef>
-          <a:effectRef idx="2">
-            <a:schemeClr val="accent1"/>
-          </a:effectRef>
-          <a:fontRef idx="minor">
-            <a:schemeClr val="lt1"/>
-          </a:fontRef>
-        </p:style>
-        <p:txBody>
-          <a:bodyPr rtlCol="0" anchor="ctr" wrap="square"/>
-          <a:lstStyle/>
-          <a:p>
-            <a:pPr algn="ctr"/>
-          </a:p>
-        </p:txBody>
-      </p:sp>
-      <p:sp>
-        <p:nvSpPr>
-          <p:cNvPr id="36" name="TextBox 35"/>
-          <p:cNvSpPr txBox="1"/>
-          <p:nvPr/>
-        </p:nvSpPr>
-        <p:spPr>
-          <a:xfrm>
-            <a:off x="10184130" y="2715768"/>
-            <a:ext cx="400278" cy="465836"/>
-          </a:xfrm>
-          <a:prstGeom prst="rect">
-            <a:avLst/>
-          </a:prstGeom>
-          <a:noFill/>
-        </p:spPr>
-        <p:txBody>
-          <a:bodyPr wrap="square" anchor="t" lIns="0" rIns="0" tIns="0" bIns="0">
-            <a:spAutoFit/>
-          </a:bodyPr>
-          <a:lstStyle/>
-          <a:p>
-            <a:pPr algn="l"/>
-            <a:r>
-              <a:rPr sz="1300" b="1" i="0">
-                <a:solidFill>
-                  <a:srgbClr val="1A0F5C"/>
-                </a:solidFill>
-                <a:latin typeface="Calibri"/>
-              </a:rPr>
-              <a:t>Resisting gaming</a:t>
-            </a:r>
-          </a:p>
-        </p:txBody>
-      </p:sp>
-      <p:sp>
-        <p:nvSpPr>
-          <p:cNvPr id="37" name="TextBox 36"/>
-          <p:cNvSpPr txBox="1"/>
-          <p:nvPr/>
-        </p:nvSpPr>
-        <p:spPr>
-          <a:xfrm>
-            <a:off x="10184130" y="3218180"/>
-            <a:ext cx="400278" cy="696976"/>
-          </a:xfrm>
-          <a:prstGeom prst="rect">
-            <a:avLst/>
-          </a:prstGeom>
-          <a:noFill/>
-        </p:spPr>
-        <p:txBody>
-          <a:bodyPr wrap="square" anchor="t" lIns="0" rIns="0" tIns="0" bIns="0">
-            <a:spAutoFit/>
-          </a:bodyPr>
-          <a:lstStyle/>
-          <a:p>
-            <a:pPr algn="l"/>
-            <a:r>
-              <a:rPr sz="1000" b="0" i="0">
-                <a:solidFill>
-                  <a:srgbClr val="6B6690"/>
-                </a:solidFill>
-                <a:latin typeface="Calibri"/>
-              </a:rPr>
-              <a:t>Pay for trips a rider asked for.</a:t>
-            </a:r>
-          </a:p>
-        </p:txBody>
-      </p:sp>
-      <p:sp>
-        <p:nvSpPr>
-          <p:cNvPr id="38" name="TextBox 37"/>
-          <p:cNvSpPr txBox="1"/>
-          <p:nvPr/>
-        </p:nvSpPr>
-        <p:spPr>
-          <a:xfrm>
-            <a:off x="10931880" y="1682496"/>
-            <a:ext cx="729462" cy="168656"/>
-          </a:xfrm>
-          <a:prstGeom prst="rect">
-            <a:avLst/>
-          </a:prstGeom>
-          <a:noFill/>
-        </p:spPr>
-        <p:txBody>
-          <a:bodyPr wrap="square" anchor="t" lIns="0" rIns="0" tIns="0" bIns="0">
-            <a:spAutoFit/>
-          </a:bodyPr>
-          <a:lstStyle/>
-          <a:p>
-            <a:pPr algn="ctr"/>
-            <a:r>
-              <a:rPr sz="800" b="1" i="0" spc="250">
-                <a:solidFill>
-                  <a:srgbClr val="5B3FD6"/>
-                </a:solidFill>
-                <a:latin typeface="Calibri"/>
-              </a:rPr>
-              <a:t>6</a:t>
-            </a:r>
-          </a:p>
-        </p:txBody>
-      </p:sp>
-      <p:sp>
-        <p:nvSpPr>
-          <p:cNvPr id="39" name="Oval 38"/>
-          <p:cNvSpPr/>
-          <p:nvPr/>
-        </p:nvSpPr>
-        <p:spPr>
-          <a:xfrm>
-            <a:off x="11196027" y="2157984"/>
-            <a:ext cx="201168" cy="201168"/>
-          </a:xfrm>
-          <a:prstGeom prst="ellipse">
-            <a:avLst/>
-          </a:prstGeom>
-          <a:solidFill>
-            <a:srgbClr val="D9A7FF"/>
-          </a:solidFill>
-          <a:ln>
-            <a:noFill/>
-          </a:ln>
-          <a:effectLst/>
-        </p:spPr>
-        <p:style>
-          <a:lnRef idx="1">
-            <a:schemeClr val="accent1"/>
-          </a:lnRef>
-          <a:fillRef idx="3">
-            <a:schemeClr val="accent1"/>
-          </a:fillRef>
-          <a:effectRef idx="2">
-            <a:schemeClr val="accent1"/>
-          </a:effectRef>
-          <a:fontRef idx="minor">
-            <a:schemeClr val="lt1"/>
-          </a:fontRef>
-        </p:style>
-        <p:txBody>
-          <a:bodyPr rtlCol="0" anchor="ctr" wrap="square"/>
-          <a:lstStyle/>
-          <a:p>
-            <a:pPr algn="ctr"/>
-          </a:p>
-        </p:txBody>
-      </p:sp>
-      <p:sp>
-        <p:nvSpPr>
-          <p:cNvPr id="40" name="Rounded Rectangle 39"/>
-          <p:cNvSpPr/>
-          <p:nvPr/>
-        </p:nvSpPr>
-        <p:spPr>
-          <a:xfrm>
-            <a:off x="10931880" y="2569464"/>
-            <a:ext cx="729462" cy="1940560"/>
-          </a:xfrm>
-          <a:prstGeom prst="roundRect">
-            <a:avLst>
-              <a:gd name="adj" fmla="val 5000"/>
-            </a:avLst>
-          </a:prstGeom>
-          <a:gradFill rotWithShape="1">
-            <a:gsLst>
-              <a:gs pos="0">
-                <a:srgbClr val="2C1A86"/>
-              </a:gs>
-              <a:gs pos="100000">
-                <a:srgbClr val="1A0F5C"/>
-              </a:gs>
-            </a:gsLst>
-            <a:lin scaled="0" ang="16200000"/>
-          </a:gradFill>
-          <a:ln>
-            <a:noFill/>
-          </a:ln>
-          <a:effectLst>
-            <a:outerShdw blurRad="76200" dist="19050" dir="5400000" algn="bl" rotWithShape="0">
-              <a:srgbClr val="1A0F5C">
-                <a:alpha val="12000"/>
-              </a:srgbClr>
-            </a:outerShdw>
-          </a:effectLst>
-        </p:spPr>
-        <p:style>
-          <a:lnRef idx="1">
-            <a:schemeClr val="accent1"/>
-          </a:lnRef>
-          <a:fillRef idx="3">
-            <a:schemeClr val="accent1"/>
-          </a:fillRef>
-          <a:effectRef idx="2">
-            <a:schemeClr val="accent1"/>
-          </a:effectRef>
-          <a:fontRef idx="minor">
-            <a:schemeClr val="lt1"/>
-          </a:fontRef>
-        </p:style>
-        <p:txBody>
-          <a:bodyPr rtlCol="0" anchor="ctr" wrap="square"/>
-          <a:lstStyle/>
-          <a:p>
-            <a:pPr algn="ctr"/>
-          </a:p>
-        </p:txBody>
-      </p:sp>
-      <p:sp>
-        <p:nvSpPr>
-          <p:cNvPr id="41" name="TextBox 40"/>
-          <p:cNvSpPr txBox="1"/>
-          <p:nvPr/>
-        </p:nvSpPr>
-        <p:spPr>
-          <a:xfrm>
-            <a:off x="11096472" y="2715768"/>
-            <a:ext cx="400278" cy="251205"/>
-          </a:xfrm>
-          <a:prstGeom prst="rect">
-            <a:avLst/>
-          </a:prstGeom>
-          <a:noFill/>
-        </p:spPr>
-        <p:txBody>
-          <a:bodyPr wrap="square" anchor="t" lIns="0" rIns="0" tIns="0" bIns="0">
-            <a:spAutoFit/>
-          </a:bodyPr>
-          <a:lstStyle/>
-          <a:p>
-            <a:pPr algn="l"/>
-            <a:r>
-              <a:rPr sz="1300" b="1" i="0">
-                <a:solidFill>
-                  <a:srgbClr val="FFFFFF"/>
-                </a:solidFill>
-                <a:latin typeface="Calibri"/>
-              </a:rPr>
-              <a:t>The page</a:t>
-            </a:r>
-          </a:p>
-        </p:txBody>
-      </p:sp>
-      <p:sp>
-        <p:nvSpPr>
-          <p:cNvPr id="42" name="TextBox 41"/>
-          <p:cNvSpPr txBox="1"/>
-          <p:nvPr/>
-        </p:nvSpPr>
-        <p:spPr>
-          <a:xfrm>
-            <a:off x="11096472" y="3003550"/>
-            <a:ext cx="400278" cy="696976"/>
-          </a:xfrm>
-          <a:prstGeom prst="rect">
-            <a:avLst/>
-          </a:prstGeom>
-          <a:noFill/>
-        </p:spPr>
-        <p:txBody>
-          <a:bodyPr wrap="square" anchor="t" lIns="0" rIns="0" tIns="0" bIns="0">
-            <a:spAutoFit/>
-          </a:bodyPr>
-          <a:lstStyle/>
-          <a:p>
-            <a:pPr algn="l"/>
-            <a:r>
-              <a:rPr sz="1000" b="0" i="0">
-                <a:solidFill>
-                  <a:srgbClr val="CFC9EE"/>
-                </a:solidFill>
-                <a:latin typeface="Calibri"/>
-              </a:rPr>
-              <a:t>Seven lines the city can sign.</a:t>
-            </a:r>
-          </a:p>
-        </p:txBody>
-      </p:sp>
-      <p:sp>
-        <p:nvSpPr>
-          <p:cNvPr id="43" name="Rounded Rectangle 42"/>
-          <p:cNvSpPr/>
-          <p:nvPr/>
-        </p:nvSpPr>
-        <p:spPr>
-          <a:xfrm>
-            <a:off x="6370167" y="4692904"/>
-            <a:ext cx="5291175" cy="1074420"/>
+            <a:off x="6370167" y="4492752"/>
+            <a:ext cx="5291175" cy="967740"/>
           </a:xfrm>
           <a:prstGeom prst="roundRect">
             <a:avLst>
@@ -11422,14 +10502,14 @@
       </p:sp>
       <p:sp>
         <p:nvSpPr>
-          <p:cNvPr id="44" name="Rounded Rectangle 43"/>
+          <p:cNvPr id="14" name="Rounded Rectangle 13"/>
           <p:cNvSpPr/>
           <p:nvPr/>
         </p:nvSpPr>
         <p:spPr>
           <a:xfrm>
-            <a:off x="6516471" y="4820920"/>
-            <a:ext cx="45720" cy="818388"/>
+            <a:off x="6516471" y="4620768"/>
+            <a:ext cx="45720" cy="711708"/>
           </a:xfrm>
           <a:prstGeom prst="roundRect">
             <a:avLst>
@@ -11468,14 +10548,14 @@
       </p:sp>
       <p:sp>
         <p:nvSpPr>
-          <p:cNvPr id="45" name="TextBox 44"/>
-          <p:cNvSpPr txBox="1"/>
-          <p:nvPr/>
-        </p:nvSpPr>
-        <p:spPr>
-          <a:xfrm>
-            <a:off x="6717639" y="4811776"/>
-            <a:ext cx="4724247" cy="891540"/>
+          <p:cNvPr id="15" name="TextBox 14"/>
+          <p:cNvSpPr txBox="1"/>
+          <p:nvPr/>
+        </p:nvSpPr>
+        <p:spPr>
+          <a:xfrm>
+            <a:off x="6717639" y="4611624"/>
+            <a:ext cx="4724247" cy="784860"/>
           </a:xfrm>
           <a:prstGeom prst="rect">
             <a:avLst/>
@@ -11489,7 +10569,7 @@
           <a:lstStyle/>
           <a:p>
             <a:r>
-              <a:rPr sz="1500" b="1">
+              <a:rPr sz="1300" b="1">
                 <a:solidFill>
                   <a:srgbClr val="5B3FD6"/>
                 </a:solidFill>
@@ -11498,7 +10578,7 @@
               <a:t>Tuesday's question. </a:t>
             </a:r>
             <a:r>
-              <a:rPr sz="1500" b="0" i="0">
+              <a:rPr sz="1300" b="0" i="0">
                 <a:solidFill>
                   <a:srgbClr val="1A1440"/>
                 </a:solidFill>
@@ -11511,7 +10591,7 @@
       </p:sp>
       <p:sp>
         <p:nvSpPr>
-          <p:cNvPr id="46" name="Oval 45"/>
+          <p:cNvPr id="16" name="Oval 15"/>
           <p:cNvSpPr/>
           <p:nvPr/>
         </p:nvSpPr>
@@ -11555,7 +10635,7 @@
       </p:sp>
       <p:sp>
         <p:nvSpPr>
-          <p:cNvPr id="47" name="TextBox 46"/>
+          <p:cNvPr id="17" name="TextBox 16"/>
           <p:cNvSpPr txBox="1"/>
           <p:nvPr/>
         </p:nvSpPr>
@@ -11590,7 +10670,7 @@
       </p:sp>
       <p:sp>
         <p:nvSpPr>
-          <p:cNvPr id="48" name="Oval 47"/>
+          <p:cNvPr id="18" name="Oval 17"/>
           <p:cNvSpPr/>
           <p:nvPr/>
         </p:nvSpPr>
@@ -11634,7 +10714,7 @@
       </p:sp>
       <p:sp>
         <p:nvSpPr>
-          <p:cNvPr id="49" name="TextBox 48"/>
+          <p:cNvPr id="19" name="TextBox 18"/>
           <p:cNvSpPr txBox="1"/>
           <p:nvPr/>
         </p:nvSpPr>
@@ -11669,7 +10749,7 @@
       </p:sp>
       <p:sp>
         <p:nvSpPr>
-          <p:cNvPr id="50" name="TextBox 49"/>
+          <p:cNvPr id="20" name="TextBox 19"/>
           <p:cNvSpPr txBox="1"/>
           <p:nvPr/>
         </p:nvSpPr>

</xml_diff>

<commit_message>
W04 D1: the leftovers the status check found, closed in every file that still carried them
The redesign solution sends the saving to notebook 10; Kahoot's question list matches Q6 and Q7;
the gaming, proxy-test, north-star, guided and artifact solutions carry the corrected VA, Wells
Fargo, Swiggy, cap and cancel-share wording; the notes name the test's unit, the wait's small fall,
Delhi Metro's withheld figure and what a count needs in place of a denominator; S84, S98 and S45
judge by trips; S93 shows the Rs 85.7 lakh and 185 trips behind Rs 46,000. Notebooks 01, 04, 07
and 09, the cheat sheet and both decks are rebuilt.

Co-Authored-By: Claude Opus 5.5 <noreply@anthropic.com>
Claude-Session: https://claude.ai/code/session_01PKfnG4dDHtQtNuxCao8MwS
</commit_message>
<xml_diff>
--- a/content/W04/D1/slides/C2_W04_D01_half2_STUDENT.pptx
+++ b/content/W04/D1/slides/C2_W04_D01_half2_STUDENT.pptx
@@ -6496,8 +6496,8 @@
           <p:nvPr/>
         </p:nvGraphicFramePr>
         <p:xfrm>
-          <a:off x="530352" y="1956816"/>
-          <a:ext cx="11130989" cy="3911600"/>
+          <a:off x="530352" y="1864360"/>
+          <a:ext cx="11130989" cy="4153408"/>
         </p:xfrm>
         <a:graphic>
           <a:graphicData uri="http://schemas.openxmlformats.org/drawingml/2006/table">
@@ -6782,7 +6782,7 @@
                   </a:tcPr>
                 </a:tc>
               </a:tr>
-              <a:tr h="853440">
+              <a:tr h="1095248">
                 <a:tc>
                   <a:txBody>
                     <a:bodyPr/>
@@ -6839,7 +6839,7 @@
                           </a:solidFill>
                           <a:latin typeface="Calibri"/>
                         </a:rPr>
-                        <a:t>180 drivers added hours on fewer trips, mostly in the outer zones, where waits fell 6.6 to 5.95 minutes at about Rs 46,000 per extra trip</a:t>
+                        <a:t>180 drivers added hours on fewer trips, mostly in the outer zones, where waits fell 6.6 to 5.95 minutes: Rs 85.7 lakh of top-up for about 185 extra trips, about Rs 46,000 each</a:t>
                       </a:r>
                     </a:p>
                   </a:txBody>
@@ -10509,7 +10509,7 @@
                           </a:solidFill>
                           <a:latin typeface="Calibri"/>
                         </a:rPr>
-                        <a:t>Pay for trips riders asked for</a:t>
+                        <a:t>Count only trips riders asked for</a:t>
                       </a:r>
                     </a:p>
                   </a:txBody>

</xml_diff>

<commit_message>
W04 D1: GCC glossed in the notebooks' tag line; growth targets named as such; the course outline replaces "the curriculum row" for learners
The day sheet's "Go as far as" says what groups write in the trainer's time and what every learner
writes in the lab. Notebooks 01, 07 and 11 and the afternoon deck are rebuilt.

Co-Authored-By: Claude Opus 5.5 <noreply@anthropic.com>
Claude-Session: https://claude.ai/code/session_01PKfnG4dDHtQtNuxCao8MwS
</commit_message>
<xml_diff>
--- a/content/W04/D1/slides/C2_W04_D01_half2_STUDENT.pptx
+++ b/content/W04/D1/slides/C2_W04_D01_half2_STUDENT.pptx
@@ -1327,12 +1327,12 @@
           </a:p>
           <a:p>
             <a:r>
-              <a:t>When it stalls: a group with a guardrail that is another growth count ("bookings per driver") is</a:t>
-            </a:r>
-          </a:p>
-          <a:p>
-            <a:r>
-              <a:t>asked what that guardrail would catch.</a:t>
+              <a:t>When it stalls: a group that offers a growth target as a guardrail ("bookings per driver up 20</a:t>
+            </a:r>
+          </a:p>
+          <a:p>
+            <a:r>
+              <a:t>percent") is asked what that guardrail would catch.</a:t>
             </a:r>
           </a:p>
           <a:p>

</xml_diff>